<commit_message>
Embed product screenshots in deck + README gallery; replay polish; honest Snyk status
Co-Authored-By: Claude Opus 5.5 <noreply@anthropic.com>
</commit_message>
<xml_diff>
--- a/deck/Haven-Pitch.pptx
+++ b/deck/Haven-Pitch.pptx
@@ -10360,7 +10360,7 @@
         </p:sp>
         <p:pic>
           <p:nvPicPr>
-            <p:cNvPr id="37" name="shot_81" descr="mock_mission-control.png"/>
+            <p:cNvPr id="37" name="shot_81" descr="mission-control.png"/>
             <p:cNvPicPr>
               <a:picLocks noChangeAspect="1"/>
             </p:cNvPicPr>
@@ -19813,7 +19813,7 @@
         </p:sp>
         <p:pic>
           <p:nvPicPr>
-            <p:cNvPr id="49" name="shot_268" descr="mock_incident-room.png"/>
+            <p:cNvPr id="49" name="shot_268" descr="incident-room.png"/>
             <p:cNvPicPr>
               <a:picLocks noChangeAspect="1"/>
             </p:cNvPicPr>
@@ -22275,7 +22275,7 @@
         </p:sp>
         <p:pic>
           <p:nvPicPr>
-            <p:cNvPr id="18" name="shot_305" descr="mock_audit.png"/>
+            <p:cNvPr id="18" name="shot_305" descr="audit.png"/>
             <p:cNvPicPr>
               <a:picLocks noChangeAspect="1"/>
             </p:cNvPicPr>

</xml_diff>